<commit_message>
minor changes chunk 6-9
</commit_message>
<xml_diff>
--- a/Lectures/Chunk 6 - Functions.pptx
+++ b/Lectures/Chunk 6 - Functions.pptx
@@ -214,12 +214,12 @@
   <pc:docChgLst>
     <pc:chgData name="Jonathan Bollig" userId="8b5d0afe-f106-45e0-8c3f-fd98fa124db1" providerId="ADAL" clId="{B2469FA9-EBD8-4834-A16D-CBF8EFC907DD}"/>
     <pc:docChg chg="undo redo custSel addSld delSld modSld">
-      <pc:chgData name="Jonathan Bollig" userId="8b5d0afe-f106-45e0-8c3f-fd98fa124db1" providerId="ADAL" clId="{B2469FA9-EBD8-4834-A16D-CBF8EFC907DD}" dt="2025-10-05T23:23:35.695" v="2902" actId="20577"/>
+      <pc:chgData name="Jonathan Bollig" userId="8b5d0afe-f106-45e0-8c3f-fd98fa124db1" providerId="ADAL" clId="{B2469FA9-EBD8-4834-A16D-CBF8EFC907DD}" dt="2025-10-07T00:02:37.309" v="2904" actId="20577"/>
       <pc:docMkLst>
         <pc:docMk/>
       </pc:docMkLst>
       <pc:sldChg chg="modSp mod">
-        <pc:chgData name="Jonathan Bollig" userId="8b5d0afe-f106-45e0-8c3f-fd98fa124db1" providerId="ADAL" clId="{B2469FA9-EBD8-4834-A16D-CBF8EFC907DD}" dt="2025-10-04T14:11:11.690" v="2474" actId="20577"/>
+        <pc:chgData name="Jonathan Bollig" userId="8b5d0afe-f106-45e0-8c3f-fd98fa124db1" providerId="ADAL" clId="{B2469FA9-EBD8-4834-A16D-CBF8EFC907DD}" dt="2025-10-07T00:02:37.309" v="2904" actId="20577"/>
         <pc:sldMkLst>
           <pc:docMk/>
           <pc:sldMk cId="836289018" sldId="256"/>
@@ -230,6 +230,14 @@
             <pc:docMk/>
             <pc:sldMk cId="836289018" sldId="256"/>
             <ac:spMk id="2" creationId="{40F72F59-52B3-6063-A2E3-2AA45125A99B}"/>
+          </ac:spMkLst>
+        </pc:spChg>
+        <pc:spChg chg="mod">
+          <ac:chgData name="Jonathan Bollig" userId="8b5d0afe-f106-45e0-8c3f-fd98fa124db1" providerId="ADAL" clId="{B2469FA9-EBD8-4834-A16D-CBF8EFC907DD}" dt="2025-10-07T00:02:37.309" v="2904" actId="20577"/>
+          <ac:spMkLst>
+            <pc:docMk/>
+            <pc:sldMk cId="836289018" sldId="256"/>
+            <ac:spMk id="3" creationId="{62F76653-44B5-8707-B179-FDB90CB514B7}"/>
           </ac:spMkLst>
         </pc:spChg>
       </pc:sldChg>
@@ -1046,22 +1054,6 @@
             <ac:spMk id="16" creationId="{7E8ED806-90DA-3F1D-1A46-ED70A61EF9C1}"/>
           </ac:spMkLst>
         </pc:spChg>
-        <pc:grpChg chg="add del mod">
-          <ac:chgData name="Jonathan Bollig" userId="8b5d0afe-f106-45e0-8c3f-fd98fa124db1" providerId="ADAL" clId="{B2469FA9-EBD8-4834-A16D-CBF8EFC907DD}" dt="2025-10-04T10:46:07.211" v="2392" actId="165"/>
-          <ac:grpSpMkLst>
-            <pc:docMk/>
-            <pc:sldMk cId="766000052" sldId="274"/>
-            <ac:grpSpMk id="10" creationId="{30C8E7FF-4728-173F-55F2-268E5172046F}"/>
-          </ac:grpSpMkLst>
-        </pc:grpChg>
-        <pc:picChg chg="add del mod">
-          <ac:chgData name="Jonathan Bollig" userId="8b5d0afe-f106-45e0-8c3f-fd98fa124db1" providerId="ADAL" clId="{B2469FA9-EBD8-4834-A16D-CBF8EFC907DD}" dt="2025-10-04T10:40:41.670" v="2269" actId="478"/>
-          <ac:picMkLst>
-            <pc:docMk/>
-            <pc:sldMk cId="766000052" sldId="274"/>
-            <ac:picMk id="5" creationId="{8922DF5F-D148-4808-25FA-233F666F7A28}"/>
-          </ac:picMkLst>
-        </pc:picChg>
         <pc:picChg chg="add mod">
           <ac:chgData name="Jonathan Bollig" userId="8b5d0afe-f106-45e0-8c3f-fd98fa124db1" providerId="ADAL" clId="{B2469FA9-EBD8-4834-A16D-CBF8EFC907DD}" dt="2025-10-04T10:43:48.320" v="2362" actId="1076"/>
           <ac:picMkLst>
@@ -1172,22 +1164,6 @@
           <pc:docMk/>
           <pc:sldMk cId="3240811298" sldId="276"/>
         </pc:sldMkLst>
-        <pc:spChg chg="mod">
-          <ac:chgData name="Jonathan Bollig" userId="8b5d0afe-f106-45e0-8c3f-fd98fa124db1" providerId="ADAL" clId="{B2469FA9-EBD8-4834-A16D-CBF8EFC907DD}" dt="2025-10-04T22:41:09.792" v="2771" actId="20577"/>
-          <ac:spMkLst>
-            <pc:docMk/>
-            <pc:sldMk cId="3240811298" sldId="276"/>
-            <ac:spMk id="2" creationId="{FDB62B56-0901-65AC-1C19-86BE19FD76EF}"/>
-          </ac:spMkLst>
-        </pc:spChg>
-        <pc:spChg chg="mod">
-          <ac:chgData name="Jonathan Bollig" userId="8b5d0afe-f106-45e0-8c3f-fd98fa124db1" providerId="ADAL" clId="{B2469FA9-EBD8-4834-A16D-CBF8EFC907DD}" dt="2025-10-04T22:41:24.008" v="2836" actId="20577"/>
-          <ac:spMkLst>
-            <pc:docMk/>
-            <pc:sldMk cId="3240811298" sldId="276"/>
-            <ac:spMk id="3" creationId="{3449A8D0-7FC2-8733-AFE5-9F14783F30BB}"/>
-          </ac:spMkLst>
-        </pc:spChg>
       </pc:sldChg>
     </pc:docChg>
   </pc:docChgLst>
@@ -1504,7 +1480,7 @@
           <a:p>
             <a:fld id="{0B6CA2EE-5589-4682-AD7F-744DBF1E81F5}" type="datetimeFigureOut">
               <a:rPr lang="de-DE" smtClean="0"/>
-              <a:t>04.10.2025</a:t>
+              <a:t>07.10.2025</a:t>
             </a:fld>
             <a:endParaRPr lang="de-DE"/>
           </a:p>
@@ -2485,7 +2461,7 @@
           <a:p>
             <a:fld id="{ADA51F25-4808-47F4-BF6E-BCDC230DB01C}" type="datetimeFigureOut">
               <a:rPr lang="de-DE" smtClean="0"/>
-              <a:t>04.10.2025</a:t>
+              <a:t>07.10.2025</a:t>
             </a:fld>
             <a:endParaRPr lang="de-DE"/>
           </a:p>
@@ -2683,7 +2659,7 @@
           <a:p>
             <a:fld id="{ADA51F25-4808-47F4-BF6E-BCDC230DB01C}" type="datetimeFigureOut">
               <a:rPr lang="de-DE" smtClean="0"/>
-              <a:t>04.10.2025</a:t>
+              <a:t>07.10.2025</a:t>
             </a:fld>
             <a:endParaRPr lang="de-DE"/>
           </a:p>
@@ -2891,7 +2867,7 @@
           <a:p>
             <a:fld id="{ADA51F25-4808-47F4-BF6E-BCDC230DB01C}" type="datetimeFigureOut">
               <a:rPr lang="de-DE" smtClean="0"/>
-              <a:t>04.10.2025</a:t>
+              <a:t>07.10.2025</a:t>
             </a:fld>
             <a:endParaRPr lang="de-DE"/>
           </a:p>
@@ -3089,7 +3065,7 @@
           <a:p>
             <a:fld id="{ADA51F25-4808-47F4-BF6E-BCDC230DB01C}" type="datetimeFigureOut">
               <a:rPr lang="de-DE" smtClean="0"/>
-              <a:t>04.10.2025</a:t>
+              <a:t>07.10.2025</a:t>
             </a:fld>
             <a:endParaRPr lang="de-DE"/>
           </a:p>
@@ -3364,7 +3340,7 @@
           <a:p>
             <a:fld id="{ADA51F25-4808-47F4-BF6E-BCDC230DB01C}" type="datetimeFigureOut">
               <a:rPr lang="de-DE" smtClean="0"/>
-              <a:t>04.10.2025</a:t>
+              <a:t>07.10.2025</a:t>
             </a:fld>
             <a:endParaRPr lang="de-DE"/>
           </a:p>
@@ -3629,7 +3605,7 @@
           <a:p>
             <a:fld id="{ADA51F25-4808-47F4-BF6E-BCDC230DB01C}" type="datetimeFigureOut">
               <a:rPr lang="de-DE" smtClean="0"/>
-              <a:t>04.10.2025</a:t>
+              <a:t>07.10.2025</a:t>
             </a:fld>
             <a:endParaRPr lang="de-DE"/>
           </a:p>
@@ -4041,7 +4017,7 @@
           <a:p>
             <a:fld id="{ADA51F25-4808-47F4-BF6E-BCDC230DB01C}" type="datetimeFigureOut">
               <a:rPr lang="de-DE" smtClean="0"/>
-              <a:t>04.10.2025</a:t>
+              <a:t>07.10.2025</a:t>
             </a:fld>
             <a:endParaRPr lang="de-DE"/>
           </a:p>
@@ -4182,7 +4158,7 @@
           <a:p>
             <a:fld id="{ADA51F25-4808-47F4-BF6E-BCDC230DB01C}" type="datetimeFigureOut">
               <a:rPr lang="de-DE" smtClean="0"/>
-              <a:t>04.10.2025</a:t>
+              <a:t>07.10.2025</a:t>
             </a:fld>
             <a:endParaRPr lang="de-DE"/>
           </a:p>
@@ -4295,7 +4271,7 @@
           <a:p>
             <a:fld id="{ADA51F25-4808-47F4-BF6E-BCDC230DB01C}" type="datetimeFigureOut">
               <a:rPr lang="de-DE" smtClean="0"/>
-              <a:t>04.10.2025</a:t>
+              <a:t>07.10.2025</a:t>
             </a:fld>
             <a:endParaRPr lang="de-DE"/>
           </a:p>
@@ -4606,7 +4582,7 @@
           <a:p>
             <a:fld id="{ADA51F25-4808-47F4-BF6E-BCDC230DB01C}" type="datetimeFigureOut">
               <a:rPr lang="de-DE" smtClean="0"/>
-              <a:t>04.10.2025</a:t>
+              <a:t>07.10.2025</a:t>
             </a:fld>
             <a:endParaRPr lang="de-DE"/>
           </a:p>
@@ -4894,7 +4870,7 @@
           <a:p>
             <a:fld id="{ADA51F25-4808-47F4-BF6E-BCDC230DB01C}" type="datetimeFigureOut">
               <a:rPr lang="de-DE" smtClean="0"/>
-              <a:t>04.10.2025</a:t>
+              <a:t>07.10.2025</a:t>
             </a:fld>
             <a:endParaRPr lang="de-DE"/>
           </a:p>
@@ -5135,7 +5111,7 @@
           <a:p>
             <a:fld id="{ADA51F25-4808-47F4-BF6E-BCDC230DB01C}" type="datetimeFigureOut">
               <a:rPr lang="de-DE" smtClean="0"/>
-              <a:t>04.10.2025</a:t>
+              <a:t>07.10.2025</a:t>
             </a:fld>
             <a:endParaRPr lang="de-DE"/>
           </a:p>
@@ -5633,9 +5609,10 @@
           </a:p>
           <a:p>
             <a:r>
-              <a:rPr lang="en-US" noProof="0" dirty="0"/>
-              <a:t>08.10.2025</a:t>
-            </a:r>
+              <a:rPr lang="en-US" noProof="0"/>
+              <a:t>09.10.2025</a:t>
+            </a:r>
+            <a:endParaRPr lang="en-US" noProof="0" dirty="0"/>
           </a:p>
         </p:txBody>
       </p:sp>

</xml_diff>

<commit_message>
Resolved merge conflict by accepting remote version of Chunk 3 pptx and included other changes
</commit_message>
<xml_diff>
--- a/Lectures/Chunk 6 - Functions.pptx
+++ b/Lectures/Chunk 6 - Functions.pptx
@@ -5,7 +5,7 @@
     <p:sldMasterId id="2147483648" r:id="rId1"/>
   </p:sldMasterIdLst>
   <p:notesMasterIdLst>
-    <p:notesMasterId r:id="rId11"/>
+    <p:notesMasterId r:id="rId10"/>
   </p:notesMasterIdLst>
   <p:sldIdLst>
     <p:sldId id="256" r:id="rId2"/>
@@ -15,8 +15,7 @@
     <p:sldId id="272" r:id="rId6"/>
     <p:sldId id="273" r:id="rId7"/>
     <p:sldId id="275" r:id="rId8"/>
-    <p:sldId id="274" r:id="rId9"/>
-    <p:sldId id="267" r:id="rId10"/>
+    <p:sldId id="267" r:id="rId9"/>
   </p:sldIdLst>
   <p:sldSz cx="12192000" cy="6858000"/>
   <p:notesSz cx="6858000" cy="9144000"/>
@@ -214,7 +213,7 @@
   <pc:docChgLst>
     <pc:chgData name="Jonathan Bollig" userId="8b5d0afe-f106-45e0-8c3f-fd98fa124db1" providerId="ADAL" clId="{B2469FA9-EBD8-4834-A16D-CBF8EFC907DD}"/>
     <pc:docChg chg="undo redo custSel addSld delSld modSld">
-      <pc:chgData name="Jonathan Bollig" userId="8b5d0afe-f106-45e0-8c3f-fd98fa124db1" providerId="ADAL" clId="{B2469FA9-EBD8-4834-A16D-CBF8EFC907DD}" dt="2025-10-07T00:02:37.309" v="2904" actId="20577"/>
+      <pc:chgData name="Jonathan Bollig" userId="8b5d0afe-f106-45e0-8c3f-fd98fa124db1" providerId="ADAL" clId="{B2469FA9-EBD8-4834-A16D-CBF8EFC907DD}" dt="2025-10-07T14:27:21.091" v="2905" actId="47"/>
       <pc:docMkLst>
         <pc:docMk/>
       </pc:docMkLst>
@@ -1000,100 +999,12 @@
           </ac:cxnSpMkLst>
         </pc:cxnChg>
       </pc:sldChg>
-      <pc:sldChg chg="addSp delSp modSp new mod modAnim">
-        <pc:chgData name="Jonathan Bollig" userId="8b5d0afe-f106-45e0-8c3f-fd98fa124db1" providerId="ADAL" clId="{B2469FA9-EBD8-4834-A16D-CBF8EFC907DD}" dt="2025-10-04T11:05:55.694" v="2468" actId="20577"/>
+      <pc:sldChg chg="addSp delSp modSp new del mod modAnim">
+        <pc:chgData name="Jonathan Bollig" userId="8b5d0afe-f106-45e0-8c3f-fd98fa124db1" providerId="ADAL" clId="{B2469FA9-EBD8-4834-A16D-CBF8EFC907DD}" dt="2025-10-07T14:27:21.091" v="2905" actId="47"/>
         <pc:sldMkLst>
           <pc:docMk/>
           <pc:sldMk cId="766000052" sldId="274"/>
         </pc:sldMkLst>
-        <pc:spChg chg="mod">
-          <ac:chgData name="Jonathan Bollig" userId="8b5d0afe-f106-45e0-8c3f-fd98fa124db1" providerId="ADAL" clId="{B2469FA9-EBD8-4834-A16D-CBF8EFC907DD}" dt="2025-10-04T11:05:55.694" v="2468" actId="20577"/>
-          <ac:spMkLst>
-            <pc:docMk/>
-            <pc:sldMk cId="766000052" sldId="274"/>
-            <ac:spMk id="2" creationId="{12E709B7-4EE2-1C5C-E005-FB19611A04F1}"/>
-          </ac:spMkLst>
-        </pc:spChg>
-        <pc:spChg chg="mod">
-          <ac:chgData name="Jonathan Bollig" userId="8b5d0afe-f106-45e0-8c3f-fd98fa124db1" providerId="ADAL" clId="{B2469FA9-EBD8-4834-A16D-CBF8EFC907DD}" dt="2025-10-04T10:44:36.585" v="2379" actId="20577"/>
-          <ac:spMkLst>
-            <pc:docMk/>
-            <pc:sldMk cId="766000052" sldId="274"/>
-            <ac:spMk id="3" creationId="{1EA530EA-7E50-248A-5926-E193D419924B}"/>
-          </ac:spMkLst>
-        </pc:spChg>
-        <pc:spChg chg="mod topLvl">
-          <ac:chgData name="Jonathan Bollig" userId="8b5d0afe-f106-45e0-8c3f-fd98fa124db1" providerId="ADAL" clId="{B2469FA9-EBD8-4834-A16D-CBF8EFC907DD}" dt="2025-10-04T10:46:07.211" v="2392" actId="165"/>
-          <ac:spMkLst>
-            <pc:docMk/>
-            <pc:sldMk cId="766000052" sldId="274"/>
-            <ac:spMk id="11" creationId="{D57928F8-5AA2-A00F-67BF-91FF78650C34}"/>
-          </ac:spMkLst>
-        </pc:spChg>
-        <pc:spChg chg="mod topLvl">
-          <ac:chgData name="Jonathan Bollig" userId="8b5d0afe-f106-45e0-8c3f-fd98fa124db1" providerId="ADAL" clId="{B2469FA9-EBD8-4834-A16D-CBF8EFC907DD}" dt="2025-10-04T10:46:07.211" v="2392" actId="165"/>
-          <ac:spMkLst>
-            <pc:docMk/>
-            <pc:sldMk cId="766000052" sldId="274"/>
-            <ac:spMk id="13" creationId="{ECD5339A-A2E5-8FBF-C3D4-9A08AAF35F98}"/>
-          </ac:spMkLst>
-        </pc:spChg>
-        <pc:spChg chg="mod topLvl">
-          <ac:chgData name="Jonathan Bollig" userId="8b5d0afe-f106-45e0-8c3f-fd98fa124db1" providerId="ADAL" clId="{B2469FA9-EBD8-4834-A16D-CBF8EFC907DD}" dt="2025-10-04T10:46:07.211" v="2392" actId="165"/>
-          <ac:spMkLst>
-            <pc:docMk/>
-            <pc:sldMk cId="766000052" sldId="274"/>
-            <ac:spMk id="14" creationId="{648C072C-1C3C-0B4A-45BE-A147665D8D81}"/>
-          </ac:spMkLst>
-        </pc:spChg>
-        <pc:spChg chg="add mod">
-          <ac:chgData name="Jonathan Bollig" userId="8b5d0afe-f106-45e0-8c3f-fd98fa124db1" providerId="ADAL" clId="{B2469FA9-EBD8-4834-A16D-CBF8EFC907DD}" dt="2025-10-04T10:46:46.714" v="2410" actId="313"/>
-          <ac:spMkLst>
-            <pc:docMk/>
-            <pc:sldMk cId="766000052" sldId="274"/>
-            <ac:spMk id="16" creationId="{7E8ED806-90DA-3F1D-1A46-ED70A61EF9C1}"/>
-          </ac:spMkLst>
-        </pc:spChg>
-        <pc:picChg chg="add mod">
-          <ac:chgData name="Jonathan Bollig" userId="8b5d0afe-f106-45e0-8c3f-fd98fa124db1" providerId="ADAL" clId="{B2469FA9-EBD8-4834-A16D-CBF8EFC907DD}" dt="2025-10-04T10:43:48.320" v="2362" actId="1076"/>
-          <ac:picMkLst>
-            <pc:docMk/>
-            <pc:sldMk cId="766000052" sldId="274"/>
-            <ac:picMk id="7" creationId="{4E3D5E86-9637-86C8-E2A5-B86CBE89A533}"/>
-          </ac:picMkLst>
-        </pc:picChg>
-        <pc:picChg chg="add mod">
-          <ac:chgData name="Jonathan Bollig" userId="8b5d0afe-f106-45e0-8c3f-fd98fa124db1" providerId="ADAL" clId="{B2469FA9-EBD8-4834-A16D-CBF8EFC907DD}" dt="2025-10-04T10:45:36.056" v="2391" actId="1076"/>
-          <ac:picMkLst>
-            <pc:docMk/>
-            <pc:sldMk cId="766000052" sldId="274"/>
-            <ac:picMk id="9" creationId="{193AA17B-8502-2E6C-A279-F908F7AD6126}"/>
-          </ac:picMkLst>
-        </pc:picChg>
-        <pc:cxnChg chg="mod topLvl">
-          <ac:chgData name="Jonathan Bollig" userId="8b5d0afe-f106-45e0-8c3f-fd98fa124db1" providerId="ADAL" clId="{B2469FA9-EBD8-4834-A16D-CBF8EFC907DD}" dt="2025-10-04T10:46:07.211" v="2392" actId="165"/>
-          <ac:cxnSpMkLst>
-            <pc:docMk/>
-            <pc:sldMk cId="766000052" sldId="274"/>
-            <ac:cxnSpMk id="12" creationId="{4E6382A4-49BE-CA6C-1A20-0724C8ABD73F}"/>
-          </ac:cxnSpMkLst>
-        </pc:cxnChg>
-        <pc:cxnChg chg="mod topLvl">
-          <ac:chgData name="Jonathan Bollig" userId="8b5d0afe-f106-45e0-8c3f-fd98fa124db1" providerId="ADAL" clId="{B2469FA9-EBD8-4834-A16D-CBF8EFC907DD}" dt="2025-10-04T10:46:07.211" v="2392" actId="165"/>
-          <ac:cxnSpMkLst>
-            <pc:docMk/>
-            <pc:sldMk cId="766000052" sldId="274"/>
-            <ac:cxnSpMk id="15" creationId="{C8DE3DA2-C424-A522-769A-457B01220394}"/>
-          </ac:cxnSpMkLst>
-        </pc:cxnChg>
-        <pc:cxnChg chg="add mod">
-          <ac:chgData name="Jonathan Bollig" userId="8b5d0afe-f106-45e0-8c3f-fd98fa124db1" providerId="ADAL" clId="{B2469FA9-EBD8-4834-A16D-CBF8EFC907DD}" dt="2025-10-04T10:46:38.443" v="2406" actId="14100"/>
-          <ac:cxnSpMkLst>
-            <pc:docMk/>
-            <pc:sldMk cId="766000052" sldId="274"/>
-            <ac:cxnSpMk id="17" creationId="{7767704C-CF9D-9F45-ED75-445B7E43F835}"/>
-          </ac:cxnSpMkLst>
-        </pc:cxnChg>
       </pc:sldChg>
       <pc:sldChg chg="addSp modSp new mod">
         <pc:chgData name="Jonathan Bollig" userId="8b5d0afe-f106-45e0-8c3f-fd98fa124db1" providerId="ADAL" clId="{B2469FA9-EBD8-4834-A16D-CBF8EFC907DD}" dt="2025-10-04T21:37:47.148" v="2744" actId="14100"/>
@@ -10586,623 +10497,6 @@
 </file>
 
 <file path=ppt/slides/slide8.xml><?xml version="1.0" encoding="utf-8"?>
-<p:sld xmlns:a="http://schemas.openxmlformats.org/drawingml/2006/main" xmlns:r="http://schemas.openxmlformats.org/officeDocument/2006/relationships" xmlns:p="http://schemas.openxmlformats.org/presentationml/2006/main">
-  <p:cSld>
-    <p:spTree>
-      <p:nvGrpSpPr>
-        <p:cNvPr id="1" name=""/>
-        <p:cNvGrpSpPr/>
-        <p:nvPr/>
-      </p:nvGrpSpPr>
-      <p:grpSpPr>
-        <a:xfrm>
-          <a:off x="0" y="0"/>
-          <a:ext cx="0" cy="0"/>
-          <a:chOff x="0" y="0"/>
-          <a:chExt cx="0" cy="0"/>
-        </a:xfrm>
-      </p:grpSpPr>
-      <p:sp>
-        <p:nvSpPr>
-          <p:cNvPr id="2" name="Titel 1">
-            <a:extLst>
-              <a:ext uri="{FF2B5EF4-FFF2-40B4-BE49-F238E27FC236}">
-                <a16:creationId xmlns:a16="http://schemas.microsoft.com/office/drawing/2014/main" id="{12E709B7-4EE2-1C5C-E005-FB19611A04F1}"/>
-              </a:ext>
-            </a:extLst>
-          </p:cNvPr>
-          <p:cNvSpPr>
-            <a:spLocks noGrp="1"/>
-          </p:cNvSpPr>
-          <p:nvPr>
-            <p:ph type="title"/>
-          </p:nvPr>
-        </p:nvSpPr>
-        <p:spPr/>
-        <p:txBody>
-          <a:bodyPr>
-            <a:normAutofit fontScale="90000"/>
-          </a:bodyPr>
-          <a:lstStyle/>
-          <a:p>
-            <a:r>
-              <a:rPr lang="en-US" dirty="0"/>
-              <a:t>**Bin </a:t>
-            </a:r>
-            <a:r>
-              <a:rPr lang="en-US" dirty="0" err="1"/>
-              <a:t>unzufrieden</a:t>
-            </a:r>
-            <a:r>
-              <a:rPr lang="en-US" dirty="0"/>
-              <a:t> </a:t>
-            </a:r>
-            <a:r>
-              <a:rPr lang="en-US" dirty="0" err="1"/>
-              <a:t>mit</a:t>
-            </a:r>
-            <a:r>
-              <a:rPr lang="en-US" dirty="0"/>
-              <a:t> dem Slide, </a:t>
-            </a:r>
-            <a:r>
-              <a:rPr lang="en-US" dirty="0" err="1"/>
-              <a:t>rausnahmen</a:t>
-            </a:r>
-            <a:r>
-              <a:rPr lang="en-US" dirty="0"/>
-              <a:t>?**</a:t>
-            </a:r>
-            <a:br>
-              <a:rPr lang="en-US" dirty="0"/>
-            </a:br>
-            <a:r>
-              <a:rPr lang="en-US" dirty="0"/>
-              <a:t>Live Coding: Variable Scopes</a:t>
-            </a:r>
-            <a:endParaRPr lang="de-DE" dirty="0"/>
-          </a:p>
-        </p:txBody>
-      </p:sp>
-      <p:sp>
-        <p:nvSpPr>
-          <p:cNvPr id="3" name="Inhaltsplatzhalter 2">
-            <a:extLst>
-              <a:ext uri="{FF2B5EF4-FFF2-40B4-BE49-F238E27FC236}">
-                <a16:creationId xmlns:a16="http://schemas.microsoft.com/office/drawing/2014/main" id="{1EA530EA-7E50-248A-5926-E193D419924B}"/>
-              </a:ext>
-            </a:extLst>
-          </p:cNvPr>
-          <p:cNvSpPr>
-            <a:spLocks noGrp="1"/>
-          </p:cNvSpPr>
-          <p:nvPr>
-            <p:ph idx="1"/>
-          </p:nvPr>
-        </p:nvSpPr>
-        <p:spPr/>
-        <p:txBody>
-          <a:bodyPr/>
-          <a:lstStyle/>
-          <a:p>
-            <a:r>
-              <a:rPr lang="en-US" dirty="0"/>
-              <a:t>“</a:t>
-            </a:r>
-            <a:r>
-              <a:rPr lang="en-US" dirty="0" err="1"/>
-              <a:t>Accesability</a:t>
-            </a:r>
-            <a:r>
-              <a:rPr lang="en-US" dirty="0"/>
-              <a:t> of variables”</a:t>
-            </a:r>
-          </a:p>
-          <a:p>
-            <a:pPr>
-              <a:buFont typeface="Wingdings" panose="05000000000000000000" pitchFamily="2" charset="2"/>
-              <a:buChar char="à"/>
-            </a:pPr>
-            <a:r>
-              <a:rPr lang="en-US" dirty="0">
-                <a:highlight>
-                  <a:srgbClr val="C0C0C0"/>
-                </a:highlight>
-                <a:sym typeface="Wingdings" panose="05000000000000000000" pitchFamily="2" charset="2"/>
-              </a:rPr>
-              <a:t>hi</a:t>
-            </a:r>
-            <a:r>
-              <a:rPr lang="en-US" dirty="0">
-                <a:sym typeface="Wingdings" panose="05000000000000000000" pitchFamily="2" charset="2"/>
-              </a:rPr>
-              <a:t> is only “known” inside the function</a:t>
-            </a:r>
-            <a:endParaRPr lang="en-US" dirty="0"/>
-          </a:p>
-          <a:p>
-            <a:endParaRPr lang="en-US" dirty="0"/>
-          </a:p>
-          <a:p>
-            <a:endParaRPr lang="de-DE" dirty="0"/>
-          </a:p>
-          <a:p>
-            <a:r>
-              <a:rPr lang="de-DE" dirty="0"/>
-              <a:t>But: This </a:t>
-            </a:r>
-            <a:r>
-              <a:rPr lang="de-DE" dirty="0" err="1"/>
-              <a:t>works</a:t>
-            </a:r>
-            <a:r>
-              <a:rPr lang="de-DE" dirty="0"/>
-              <a:t>?</a:t>
-            </a:r>
-          </a:p>
-        </p:txBody>
-      </p:sp>
-      <p:pic>
-        <p:nvPicPr>
-          <p:cNvPr id="7" name="Grafik 6">
-            <a:extLst>
-              <a:ext uri="{FF2B5EF4-FFF2-40B4-BE49-F238E27FC236}">
-                <a16:creationId xmlns:a16="http://schemas.microsoft.com/office/drawing/2014/main" id="{4E3D5E86-9637-86C8-E2A5-B86CBE89A533}"/>
-              </a:ext>
-            </a:extLst>
-          </p:cNvPr>
-          <p:cNvPicPr>
-            <a:picLocks noChangeAspect="1"/>
-          </p:cNvPicPr>
-          <p:nvPr/>
-        </p:nvPicPr>
-        <p:blipFill>
-          <a:blip r:embed="rId2"/>
-          <a:stretch>
-            <a:fillRect/>
-          </a:stretch>
-        </p:blipFill>
-        <p:spPr>
-          <a:xfrm>
-            <a:off x="7997638" y="857815"/>
-            <a:ext cx="2211638" cy="2361511"/>
-          </a:xfrm>
-          <a:prstGeom prst="rect">
-            <a:avLst/>
-          </a:prstGeom>
-          <a:ln>
-            <a:noFill/>
-          </a:ln>
-          <a:effectLst>
-            <a:outerShdw blurRad="292100" dist="139700" dir="2700000" algn="tl" rotWithShape="0">
-              <a:srgbClr val="333333">
-                <a:alpha val="65000"/>
-              </a:srgbClr>
-            </a:outerShdw>
-          </a:effectLst>
-        </p:spPr>
-      </p:pic>
-      <p:pic>
-        <p:nvPicPr>
-          <p:cNvPr id="9" name="Grafik 8">
-            <a:extLst>
-              <a:ext uri="{FF2B5EF4-FFF2-40B4-BE49-F238E27FC236}">
-                <a16:creationId xmlns:a16="http://schemas.microsoft.com/office/drawing/2014/main" id="{193AA17B-8502-2E6C-A279-F908F7AD6126}"/>
-              </a:ext>
-            </a:extLst>
-          </p:cNvPr>
-          <p:cNvPicPr>
-            <a:picLocks noChangeAspect="1"/>
-          </p:cNvPicPr>
-          <p:nvPr/>
-        </p:nvPicPr>
-        <p:blipFill>
-          <a:blip r:embed="rId3"/>
-          <a:stretch>
-            <a:fillRect/>
-          </a:stretch>
-        </p:blipFill>
-        <p:spPr>
-          <a:xfrm>
-            <a:off x="4659372" y="3219326"/>
-            <a:ext cx="1970028" cy="1893867"/>
-          </a:xfrm>
-          <a:prstGeom prst="rect">
-            <a:avLst/>
-          </a:prstGeom>
-          <a:ln>
-            <a:noFill/>
-          </a:ln>
-          <a:effectLst>
-            <a:outerShdw blurRad="292100" dist="139700" dir="2700000" algn="tl" rotWithShape="0">
-              <a:srgbClr val="333333">
-                <a:alpha val="65000"/>
-              </a:srgbClr>
-            </a:outerShdw>
-          </a:effectLst>
-        </p:spPr>
-      </p:pic>
-      <p:sp>
-        <p:nvSpPr>
-          <p:cNvPr id="11" name="Rechteck: abgerundete Ecken 10">
-            <a:extLst>
-              <a:ext uri="{FF2B5EF4-FFF2-40B4-BE49-F238E27FC236}">
-                <a16:creationId xmlns:a16="http://schemas.microsoft.com/office/drawing/2014/main" id="{D57928F8-5AA2-A00F-67BF-91FF78650C34}"/>
-              </a:ext>
-            </a:extLst>
-          </p:cNvPr>
-          <p:cNvSpPr/>
-          <p:nvPr/>
-        </p:nvSpPr>
-        <p:spPr>
-          <a:xfrm>
-            <a:off x="4530853" y="5579561"/>
-            <a:ext cx="2733427" cy="841248"/>
-          </a:xfrm>
-          <a:prstGeom prst="roundRect">
-            <a:avLst/>
-          </a:prstGeom>
-          <a:solidFill>
-            <a:srgbClr val="FFFFCC"/>
-          </a:solidFill>
-        </p:spPr>
-        <p:style>
-          <a:lnRef idx="2">
-            <a:schemeClr val="accent1">
-              <a:shade val="15000"/>
-            </a:schemeClr>
-          </a:lnRef>
-          <a:fillRef idx="1">
-            <a:schemeClr val="accent1"/>
-          </a:fillRef>
-          <a:effectRef idx="0">
-            <a:schemeClr val="accent1"/>
-          </a:effectRef>
-          <a:fontRef idx="minor">
-            <a:schemeClr val="lt1"/>
-          </a:fontRef>
-        </p:style>
-        <p:txBody>
-          <a:bodyPr rtlCol="0" anchor="ctr"/>
-          <a:lstStyle/>
-          <a:p>
-            <a:pPr algn="ctr"/>
-            <a:r>
-              <a:rPr lang="en-GB" noProof="0" dirty="0">
-                <a:solidFill>
-                  <a:schemeClr val="tx1"/>
-                </a:solidFill>
-              </a:rPr>
-              <a:t>Function Logic</a:t>
-            </a:r>
-          </a:p>
-        </p:txBody>
-      </p:sp>
-      <p:cxnSp>
-        <p:nvCxnSpPr>
-          <p:cNvPr id="12" name="Gerade Verbindung mit Pfeil 11">
-            <a:extLst>
-              <a:ext uri="{FF2B5EF4-FFF2-40B4-BE49-F238E27FC236}">
-                <a16:creationId xmlns:a16="http://schemas.microsoft.com/office/drawing/2014/main" id="{4E6382A4-49BE-CA6C-1A20-0724C8ABD73F}"/>
-              </a:ext>
-            </a:extLst>
-          </p:cNvPr>
-          <p:cNvCxnSpPr>
-            <a:cxnSpLocks/>
-            <a:stCxn id="13" idx="3"/>
-            <a:endCxn id="11" idx="1"/>
-          </p:cNvCxnSpPr>
-          <p:nvPr/>
-        </p:nvCxnSpPr>
-        <p:spPr>
-          <a:xfrm>
-            <a:off x="4087816" y="6000185"/>
-            <a:ext cx="443037" cy="0"/>
-          </a:xfrm>
-          <a:prstGeom prst="straightConnector1">
-            <a:avLst/>
-          </a:prstGeom>
-          <a:ln>
-            <a:headEnd type="none" w="med" len="med"/>
-            <a:tailEnd type="arrow" w="med" len="med"/>
-          </a:ln>
-        </p:spPr>
-        <p:style>
-          <a:lnRef idx="3">
-            <a:schemeClr val="dk1"/>
-          </a:lnRef>
-          <a:fillRef idx="0">
-            <a:schemeClr val="dk1"/>
-          </a:fillRef>
-          <a:effectRef idx="2">
-            <a:schemeClr val="dk1"/>
-          </a:effectRef>
-          <a:fontRef idx="minor">
-            <a:schemeClr val="tx1"/>
-          </a:fontRef>
-        </p:style>
-      </p:cxnSp>
-      <p:sp>
-        <p:nvSpPr>
-          <p:cNvPr id="13" name="Rechteck: abgerundete Ecken 12">
-            <a:extLst>
-              <a:ext uri="{FF2B5EF4-FFF2-40B4-BE49-F238E27FC236}">
-                <a16:creationId xmlns:a16="http://schemas.microsoft.com/office/drawing/2014/main" id="{ECD5339A-A2E5-8FBF-C3D4-9A08AAF35F98}"/>
-              </a:ext>
-            </a:extLst>
-          </p:cNvPr>
-          <p:cNvSpPr/>
-          <p:nvPr/>
-        </p:nvSpPr>
-        <p:spPr>
-          <a:xfrm>
-            <a:off x="2939796" y="5579561"/>
-            <a:ext cx="1148020" cy="841248"/>
-          </a:xfrm>
-          <a:prstGeom prst="roundRect">
-            <a:avLst/>
-          </a:prstGeom>
-          <a:solidFill>
-            <a:srgbClr val="FFFFCC"/>
-          </a:solidFill>
-        </p:spPr>
-        <p:style>
-          <a:lnRef idx="2">
-            <a:schemeClr val="accent1">
-              <a:shade val="15000"/>
-            </a:schemeClr>
-          </a:lnRef>
-          <a:fillRef idx="1">
-            <a:schemeClr val="accent1"/>
-          </a:fillRef>
-          <a:effectRef idx="0">
-            <a:schemeClr val="accent1"/>
-          </a:effectRef>
-          <a:fontRef idx="minor">
-            <a:schemeClr val="lt1"/>
-          </a:fontRef>
-        </p:style>
-        <p:txBody>
-          <a:bodyPr rtlCol="0" anchor="ctr"/>
-          <a:lstStyle/>
-          <a:p>
-            <a:pPr algn="ctr"/>
-            <a:r>
-              <a:rPr lang="en-GB" noProof="0" dirty="0">
-                <a:solidFill>
-                  <a:schemeClr val="tx1"/>
-                </a:solidFill>
-              </a:rPr>
-              <a:t>Input</a:t>
-            </a:r>
-          </a:p>
-        </p:txBody>
-      </p:sp>
-      <p:sp>
-        <p:nvSpPr>
-          <p:cNvPr id="14" name="Rechteck: abgerundete Ecken 13">
-            <a:extLst>
-              <a:ext uri="{FF2B5EF4-FFF2-40B4-BE49-F238E27FC236}">
-                <a16:creationId xmlns:a16="http://schemas.microsoft.com/office/drawing/2014/main" id="{648C072C-1C3C-0B4A-45BE-A147665D8D81}"/>
-              </a:ext>
-            </a:extLst>
-          </p:cNvPr>
-          <p:cNvSpPr/>
-          <p:nvPr/>
-        </p:nvSpPr>
-        <p:spPr>
-          <a:xfrm>
-            <a:off x="7707317" y="5579561"/>
-            <a:ext cx="1148647" cy="841248"/>
-          </a:xfrm>
-          <a:prstGeom prst="roundRect">
-            <a:avLst/>
-          </a:prstGeom>
-          <a:solidFill>
-            <a:srgbClr val="FFFFCC"/>
-          </a:solidFill>
-        </p:spPr>
-        <p:style>
-          <a:lnRef idx="2">
-            <a:schemeClr val="accent1">
-              <a:shade val="15000"/>
-            </a:schemeClr>
-          </a:lnRef>
-          <a:fillRef idx="1">
-            <a:schemeClr val="accent1"/>
-          </a:fillRef>
-          <a:effectRef idx="0">
-            <a:schemeClr val="accent1"/>
-          </a:effectRef>
-          <a:fontRef idx="minor">
-            <a:schemeClr val="lt1"/>
-          </a:fontRef>
-        </p:style>
-        <p:txBody>
-          <a:bodyPr rtlCol="0" anchor="ctr"/>
-          <a:lstStyle/>
-          <a:p>
-            <a:pPr algn="ctr"/>
-            <a:r>
-              <a:rPr lang="en-GB" noProof="0" dirty="0">
-                <a:solidFill>
-                  <a:schemeClr val="tx1"/>
-                </a:solidFill>
-              </a:rPr>
-              <a:t>Output</a:t>
-            </a:r>
-          </a:p>
-        </p:txBody>
-      </p:sp>
-      <p:cxnSp>
-        <p:nvCxnSpPr>
-          <p:cNvPr id="15" name="Gerade Verbindung mit Pfeil 14">
-            <a:extLst>
-              <a:ext uri="{FF2B5EF4-FFF2-40B4-BE49-F238E27FC236}">
-                <a16:creationId xmlns:a16="http://schemas.microsoft.com/office/drawing/2014/main" id="{C8DE3DA2-C424-A522-769A-457B01220394}"/>
-              </a:ext>
-            </a:extLst>
-          </p:cNvPr>
-          <p:cNvCxnSpPr>
-            <a:cxnSpLocks/>
-            <a:stCxn id="11" idx="3"/>
-            <a:endCxn id="14" idx="1"/>
-          </p:cNvCxnSpPr>
-          <p:nvPr/>
-        </p:nvCxnSpPr>
-        <p:spPr>
-          <a:xfrm>
-            <a:off x="7264280" y="6000185"/>
-            <a:ext cx="443037" cy="0"/>
-          </a:xfrm>
-          <a:prstGeom prst="straightConnector1">
-            <a:avLst/>
-          </a:prstGeom>
-          <a:ln>
-            <a:headEnd type="none" w="med" len="med"/>
-            <a:tailEnd type="arrow" w="med" len="med"/>
-          </a:ln>
-        </p:spPr>
-        <p:style>
-          <a:lnRef idx="3">
-            <a:schemeClr val="dk1"/>
-          </a:lnRef>
-          <a:fillRef idx="0">
-            <a:schemeClr val="dk1"/>
-          </a:fillRef>
-          <a:effectRef idx="2">
-            <a:schemeClr val="dk1"/>
-          </a:effectRef>
-          <a:fontRef idx="minor">
-            <a:schemeClr val="tx1"/>
-          </a:fontRef>
-        </p:style>
-      </p:cxnSp>
-      <p:sp>
-        <p:nvSpPr>
-          <p:cNvPr id="16" name="Rechteck: abgerundete Ecken 15">
-            <a:extLst>
-              <a:ext uri="{FF2B5EF4-FFF2-40B4-BE49-F238E27FC236}">
-                <a16:creationId xmlns:a16="http://schemas.microsoft.com/office/drawing/2014/main" id="{7E8ED806-90DA-3F1D-1A46-ED70A61EF9C1}"/>
-              </a:ext>
-            </a:extLst>
-          </p:cNvPr>
-          <p:cNvSpPr/>
-          <p:nvPr/>
-        </p:nvSpPr>
-        <p:spPr>
-          <a:xfrm>
-            <a:off x="2939796" y="4528001"/>
-            <a:ext cx="1148020" cy="841248"/>
-          </a:xfrm>
-          <a:prstGeom prst="roundRect">
-            <a:avLst/>
-          </a:prstGeom>
-          <a:solidFill>
-            <a:srgbClr val="FFFFCC"/>
-          </a:solidFill>
-        </p:spPr>
-        <p:style>
-          <a:lnRef idx="2">
-            <a:schemeClr val="accent1">
-              <a:shade val="15000"/>
-            </a:schemeClr>
-          </a:lnRef>
-          <a:fillRef idx="1">
-            <a:schemeClr val="accent1"/>
-          </a:fillRef>
-          <a:effectRef idx="0">
-            <a:schemeClr val="accent1"/>
-          </a:effectRef>
-          <a:fontRef idx="minor">
-            <a:schemeClr val="lt1"/>
-          </a:fontRef>
-        </p:style>
-        <p:txBody>
-          <a:bodyPr rtlCol="0" anchor="ctr"/>
-          <a:lstStyle/>
-          <a:p>
-            <a:pPr algn="ctr"/>
-            <a:r>
-              <a:rPr lang="en-GB" noProof="0" dirty="0">
-                <a:solidFill>
-                  <a:schemeClr val="tx1"/>
-                </a:solidFill>
-              </a:rPr>
-              <a:t>“Global</a:t>
-            </a:r>
-          </a:p>
-          <a:p>
-            <a:pPr algn="ctr"/>
-            <a:r>
-              <a:rPr lang="en-GB" noProof="0" dirty="0">
-                <a:solidFill>
-                  <a:schemeClr val="tx1"/>
-                </a:solidFill>
-              </a:rPr>
-              <a:t>Input”</a:t>
-            </a:r>
-          </a:p>
-        </p:txBody>
-      </p:sp>
-      <p:cxnSp>
-        <p:nvCxnSpPr>
-          <p:cNvPr id="17" name="Gerade Verbindung mit Pfeil 16">
-            <a:extLst>
-              <a:ext uri="{FF2B5EF4-FFF2-40B4-BE49-F238E27FC236}">
-                <a16:creationId xmlns:a16="http://schemas.microsoft.com/office/drawing/2014/main" id="{7767704C-CF9D-9F45-ED75-445B7E43F835}"/>
-              </a:ext>
-            </a:extLst>
-          </p:cNvPr>
-          <p:cNvCxnSpPr>
-            <a:cxnSpLocks/>
-            <a:stCxn id="16" idx="3"/>
-            <a:endCxn id="11" idx="1"/>
-          </p:cNvCxnSpPr>
-          <p:nvPr/>
-        </p:nvCxnSpPr>
-        <p:spPr>
-          <a:xfrm>
-            <a:off x="4087816" y="4948625"/>
-            <a:ext cx="443037" cy="1051560"/>
-          </a:xfrm>
-          <a:prstGeom prst="straightConnector1">
-            <a:avLst/>
-          </a:prstGeom>
-          <a:ln>
-            <a:headEnd type="none" w="med" len="med"/>
-            <a:tailEnd type="arrow" w="med" len="med"/>
-          </a:ln>
-        </p:spPr>
-        <p:style>
-          <a:lnRef idx="3">
-            <a:schemeClr val="dk1"/>
-          </a:lnRef>
-          <a:fillRef idx="0">
-            <a:schemeClr val="dk1"/>
-          </a:fillRef>
-          <a:effectRef idx="2">
-            <a:schemeClr val="dk1"/>
-          </a:effectRef>
-          <a:fontRef idx="minor">
-            <a:schemeClr val="tx1"/>
-          </a:fontRef>
-        </p:style>
-      </p:cxnSp>
-    </p:spTree>
-    <p:extLst>
-      <p:ext uri="{BB962C8B-B14F-4D97-AF65-F5344CB8AC3E}">
-        <p14:creationId xmlns:p14="http://schemas.microsoft.com/office/powerpoint/2010/main" val="766000052"/>
-      </p:ext>
-    </p:extLst>
-  </p:cSld>
-  <p:clrMapOvr>
-    <a:masterClrMapping/>
-  </p:clrMapOvr>
-</p:sld>
-</file>
-
-<file path=ppt/slides/slide9.xml><?xml version="1.0" encoding="utf-8"?>
 <p:sld xmlns:a="http://schemas.openxmlformats.org/drawingml/2006/main" xmlns:r="http://schemas.openxmlformats.org/officeDocument/2006/relationships" xmlns:p="http://schemas.openxmlformats.org/presentationml/2006/main">
   <p:cSld>
     <p:spTree>

</xml_diff>